<commit_message>
White paper v4.1 §5.2: describe implemented envelope delivery; corrected ceremony diagram
The single-read drop point was presented as implemented but is only
designed. Delivery bullet now describes the identity-addressed fetch
during a recovery session; diagram copy ceremony-envelope-flow-v4.1.png
replaces 'single-read drop point, fetched once' in the v4.1 paper and
talk deck slide 14 (original PNG kept for v4.0/archived papers).

Fine-tuned, vetted, and, in some cases, supplemented by Claude Sonnet 5
</commit_message>
<xml_diff>
--- a/docs/shardic_deck_v4_1_1_conference_talk.pptx
+++ b/docs/shardic_deck_v4_1_1_conference_talk.pptx
@@ -879,7 +879,7 @@
           <a:lstStyle/>
           <a:p>
             <a:r>
-              <a:t>[0:25–0:27] What makes Level 2 more than a CLI. Registration: trustees come from a dedicated Keycloak group and generate their own keypairs on their own devices — the private key never touches a server shardic controls. Formation: an operator with the shardic-operator role picks T trustees plus an ordered backup list; declines and timeouts backfill automatically, race-safe; and the operator can't pick themselves. Delivery: each trustee fetches their own wrapped envelope, addressed by authenticated identity (a single-read drop point is designed but not built yet — say so if asked). Recovery: the combiner only ever receives unsealed shards, never a codeword. The organizing principle: a compromised identity provider or a stalled ceremony can block provisioning, but neither can weaken D-of-T.</a:t>
+              <a:t>[0:25–0:27] What makes Level 2 more than a CLI. Registration: trustees come from a dedicated Keycloak group and generate their own keypairs on their own devices — the private key never touches a server shardic controls. Formation: an operator with the shardic-operator role picks T trustees plus an ordered backup list; declines and timeouts backfill automatically, race-safe; and the operator can't pick themselves. Delivery: each trustee fetches their own wrapped envelope, addressed by authenticated identity (a single-read drop point is designed but not built yet — the paper says so too). Recovery: the combiner only ever receives unsealed shards, never a codeword. The organizing principle: a compromised identity provider or a stalled ceremony can block provisioning, but neither can weaken D-of-T.</a:t>
             </a:r>
           </a:p>
         </p:txBody>
@@ -9828,7 +9828,7 @@
       </p:sp>
       <p:pic>
         <p:nvPicPr>
-          <p:cNvPr id="7" name="Picture 6" descr="ceremony-envelope-flow.png"/>
+          <p:cNvPr id="7" name="Picture 6" descr="ceremony-envelope-flow-v4.1.png"/>
           <p:cNvPicPr>
             <a:picLocks noChangeAspect="1"/>
           </p:cNvPicPr>

</xml_diff>

<commit_message>
Talk deck v4.1.1: spell out SPAC (shardic protected action code) on slides 13 and 15
Fine-tuned, vetted, and, in some cases, supplemented by Claude Sonnet 5
</commit_message>
<xml_diff>
--- a/docs/shardic_deck_v4_1_1_conference_talk.pptx
+++ b/docs/shardic_deck_v4_1_1_conference_talk.pptx
@@ -949,7 +949,7 @@
           <a:lstStyle/>
           <a:p>
             <a:r>
-              <a:t>[0:27] The plaintext never had to be a file. A SPAC is any enabling value: a signing key, a release-enable code. The Fielded Prime Element reuses shardic-prime's mask so a copied CT SPAC plus a legitimate quorum still fails on the wrong hardware. Precedent: Permissive Action Links, Two-Person Integrity.</a:t>
+              <a:t>[0:27] The plaintext never had to be a file. SPAC stands for shardic protected action code: any enabling value: a signing key, a release-enable code. The Fielded Prime Element reuses shardic-prime's mask so a copied CT SPAC plus a legitimate quorum still fails on the wrong hardware. Precedent: Permissive Action Links, Two-Person Integrity.</a:t>
             </a:r>
           </a:p>
         </p:txBody>
@@ -9474,7 +9474,7 @@
                 </a:solidFill>
                 <a:latin typeface="Calibri"/>
               </a:rPr>
-              <a:t>Gate any consequential action</a:t>
+              <a:t>Shardic protected action code: gate any consequential action</a:t>
             </a:r>
           </a:p>
           <a:p>
@@ -10629,6 +10629,50 @@
         </p:nvSpPr>
         <p:spPr>
           <a:xfrm>
+            <a:off x="548640" y="1188720"/>
+            <a:ext cx="11064240" cy="548640"/>
+          </a:xfrm>
+          <a:prstGeom prst="rect">
+            <a:avLst/>
+          </a:prstGeom>
+          <a:noFill/>
+        </p:spPr>
+        <p:txBody>
+          <a:bodyPr wrap="square" lIns="0" rIns="0" tIns="0" bIns="0" anchor="t">
+            <a:spAutoFit/>
+          </a:bodyPr>
+          <a:lstStyle/>
+          <a:p>
+            <a:pPr algn="l"/>
+            <a:r>
+              <a:rPr sz="1500" b="1" i="0">
+                <a:solidFill>
+                  <a:srgbClr val="5B6B8C"/>
+                </a:solidFill>
+                <a:latin typeface="Calibri"/>
+              </a:rPr>
+              <a:t>SPAC — shardic protected action code:</a:t>
+            </a:r>
+            <a:r>
+              <a:rPr sz="1500" b="0" i="0">
+                <a:solidFill>
+                  <a:srgbClr val="5B6B8C"/>
+                </a:solidFill>
+                <a:latin typeface="Calibri"/>
+              </a:rPr>
+              <a:t> the enabling value for a consequential action, held under the same D-of-T rule as a file's key.</a:t>
+            </a:r>
+          </a:p>
+        </p:txBody>
+      </p:sp>
+      <p:sp>
+        <p:nvSpPr>
+          <p:cNvPr id="5" name="TextBox 4"/>
+          <p:cNvSpPr txBox="1"/>
+          <p:nvPr/>
+        </p:nvSpPr>
+        <p:spPr>
+          <a:xfrm>
             <a:off x="548640" y="6419088"/>
             <a:ext cx="5486400" cy="256032"/>
           </a:xfrm>
@@ -10658,7 +10702,7 @@
       </p:sp>
       <p:sp>
         <p:nvSpPr>
-          <p:cNvPr id="5" name="TextBox 4"/>
+          <p:cNvPr id="6" name="TextBox 5"/>
           <p:cNvSpPr txBox="1"/>
           <p:nvPr/>
         </p:nvSpPr>
@@ -10693,14 +10737,14 @@
       </p:sp>
       <p:sp>
         <p:nvSpPr>
-          <p:cNvPr id="6" name="Rounded Rectangle 5"/>
+          <p:cNvPr id="7" name="Rounded Rectangle 6"/>
           <p:cNvSpPr/>
           <p:nvPr/>
         </p:nvSpPr>
         <p:spPr>
           <a:xfrm>
-            <a:off x="548640" y="1554480"/>
-            <a:ext cx="3520440" cy="3200400"/>
+            <a:off x="548640" y="1828800"/>
+            <a:ext cx="3520440" cy="2971800"/>
           </a:xfrm>
           <a:prstGeom prst="roundRect">
             <a:avLst>
@@ -10737,13 +10781,13 @@
       </p:sp>
       <p:sp>
         <p:nvSpPr>
-          <p:cNvPr id="7" name="Oval 6"/>
+          <p:cNvPr id="8" name="Oval 7"/>
           <p:cNvSpPr/>
           <p:nvPr/>
         </p:nvSpPr>
         <p:spPr>
           <a:xfrm>
-            <a:off x="822959" y="1828800"/>
+            <a:off x="822959" y="2103120"/>
             <a:ext cx="512064" cy="512064"/>
           </a:xfrm>
           <a:prstGeom prst="ellipse">
@@ -10781,7 +10825,7 @@
       </p:sp>
       <p:pic>
         <p:nvPicPr>
-          <p:cNvPr id="8" name="Picture 7" descr="image-7-2.png"/>
+          <p:cNvPr id="9" name="Picture 8" descr="image-7-2.png"/>
           <p:cNvPicPr>
             <a:picLocks noChangeAspect="1"/>
           </p:cNvPicPr>
@@ -10795,7 +10839,7 @@
         </p:blipFill>
         <p:spPr>
           <a:xfrm>
-            <a:off x="945855" y="1951695"/>
+            <a:off x="945855" y="2226015"/>
             <a:ext cx="266273" cy="266273"/>
           </a:xfrm>
           <a:prstGeom prst="rect">
@@ -10805,13 +10849,13 @@
       </p:pic>
       <p:sp>
         <p:nvSpPr>
-          <p:cNvPr id="9" name="TextBox 8"/>
-          <p:cNvSpPr txBox="1"/>
-          <p:nvPr/>
-        </p:nvSpPr>
-        <p:spPr>
-          <a:xfrm>
-            <a:off x="822959" y="2487168"/>
+          <p:cNvPr id="10" name="TextBox 9"/>
+          <p:cNvSpPr txBox="1"/>
+          <p:nvPr/>
+        </p:nvSpPr>
+        <p:spPr>
+          <a:xfrm>
+            <a:off x="822959" y="2761488"/>
             <a:ext cx="2971800" cy="457200"/>
           </a:xfrm>
           <a:prstGeom prst="rect">
@@ -10840,14 +10884,14 @@
       </p:sp>
       <p:sp>
         <p:nvSpPr>
-          <p:cNvPr id="10" name="TextBox 9"/>
-          <p:cNvSpPr txBox="1"/>
-          <p:nvPr/>
-        </p:nvSpPr>
-        <p:spPr>
-          <a:xfrm>
-            <a:off x="822959" y="2869184"/>
-            <a:ext cx="2971800" cy="1702816"/>
+          <p:cNvPr id="11" name="TextBox 10"/>
+          <p:cNvSpPr txBox="1"/>
+          <p:nvPr/>
+        </p:nvSpPr>
+        <p:spPr>
+          <a:xfrm>
+            <a:off x="822959" y="3143504"/>
+            <a:ext cx="2971800" cy="1474216"/>
           </a:xfrm>
           <a:prstGeom prst="rect">
             <a:avLst/>
@@ -10868,21 +10912,21 @@
                 </a:solidFill>
                 <a:latin typeface="Calibri"/>
               </a:rPr>
-              <a:t>Any enabling value — a signing credential, a release-enable code — encrypted and split exactly like a file's key.</a:t>
-            </a:r>
-          </a:p>
-        </p:txBody>
-      </p:sp>
-      <p:sp>
-        <p:nvSpPr>
-          <p:cNvPr id="11" name="Rounded Rectangle 10"/>
+              <a:t>Plaintext SPAC in, ciphertext SPAC out — a signing credential or release-enable code, encrypted and split exactly like a file's key.</a:t>
+            </a:r>
+          </a:p>
+        </p:txBody>
+      </p:sp>
+      <p:sp>
+        <p:nvSpPr>
+          <p:cNvPr id="12" name="Rounded Rectangle 11"/>
           <p:cNvSpPr/>
           <p:nvPr/>
         </p:nvSpPr>
         <p:spPr>
           <a:xfrm>
-            <a:off x="4297680" y="1554480"/>
-            <a:ext cx="3520440" cy="3200400"/>
+            <a:off x="4297680" y="1828800"/>
+            <a:ext cx="3520440" cy="2971800"/>
           </a:xfrm>
           <a:prstGeom prst="roundRect">
             <a:avLst>
@@ -10919,13 +10963,13 @@
       </p:sp>
       <p:sp>
         <p:nvSpPr>
-          <p:cNvPr id="12" name="Oval 11"/>
+          <p:cNvPr id="13" name="Oval 12"/>
           <p:cNvSpPr/>
           <p:nvPr/>
         </p:nvSpPr>
         <p:spPr>
           <a:xfrm>
-            <a:off x="4572000" y="1828800"/>
+            <a:off x="4572000" y="2103120"/>
             <a:ext cx="512064" cy="512064"/>
           </a:xfrm>
           <a:prstGeom prst="ellipse">
@@ -10963,7 +11007,7 @@
       </p:sp>
       <p:pic>
         <p:nvPicPr>
-          <p:cNvPr id="13" name="Picture 12" descr="image-4-1.png"/>
+          <p:cNvPr id="14" name="Picture 13" descr="image-4-1.png"/>
           <p:cNvPicPr>
             <a:picLocks noChangeAspect="1"/>
           </p:cNvPicPr>
@@ -10977,7 +11021,7 @@
         </p:blipFill>
         <p:spPr>
           <a:xfrm>
-            <a:off x="4694895" y="1951695"/>
+            <a:off x="4694895" y="2226015"/>
             <a:ext cx="266273" cy="266273"/>
           </a:xfrm>
           <a:prstGeom prst="rect">
@@ -10987,13 +11031,13 @@
       </p:pic>
       <p:sp>
         <p:nvSpPr>
-          <p:cNvPr id="14" name="TextBox 13"/>
-          <p:cNvSpPr txBox="1"/>
-          <p:nvPr/>
-        </p:nvSpPr>
-        <p:spPr>
-          <a:xfrm>
-            <a:off x="4572000" y="2487168"/>
+          <p:cNvPr id="15" name="TextBox 14"/>
+          <p:cNvSpPr txBox="1"/>
+          <p:nvPr/>
+        </p:nvSpPr>
+        <p:spPr>
+          <a:xfrm>
+            <a:off x="4572000" y="2761488"/>
             <a:ext cx="2971800" cy="457200"/>
           </a:xfrm>
           <a:prstGeom prst="rect">
@@ -11022,14 +11066,14 @@
       </p:sp>
       <p:sp>
         <p:nvSpPr>
-          <p:cNvPr id="15" name="TextBox 14"/>
-          <p:cNvSpPr txBox="1"/>
-          <p:nvPr/>
-        </p:nvSpPr>
-        <p:spPr>
-          <a:xfrm>
-            <a:off x="4572000" y="2869184"/>
-            <a:ext cx="2971800" cy="1702816"/>
+          <p:cNvPr id="16" name="TextBox 15"/>
+          <p:cNvSpPr txBox="1"/>
+          <p:nvPr/>
+        </p:nvSpPr>
+        <p:spPr>
+          <a:xfrm>
+            <a:off x="4572000" y="3143504"/>
+            <a:ext cx="2971800" cy="1474216"/>
           </a:xfrm>
           <a:prstGeom prst="rect">
             <a:avLst/>
@@ -11057,14 +11101,14 @@
       </p:sp>
       <p:sp>
         <p:nvSpPr>
-          <p:cNvPr id="16" name="Rounded Rectangle 15"/>
+          <p:cNvPr id="17" name="Rounded Rectangle 16"/>
           <p:cNvSpPr/>
           <p:nvPr/>
         </p:nvSpPr>
         <p:spPr>
           <a:xfrm>
-            <a:off x="8046720" y="1554480"/>
-            <a:ext cx="3566160" cy="3200400"/>
+            <a:off x="8046720" y="1828800"/>
+            <a:ext cx="3566160" cy="2971800"/>
           </a:xfrm>
           <a:prstGeom prst="roundRect">
             <a:avLst>
@@ -11101,13 +11145,13 @@
       </p:sp>
       <p:sp>
         <p:nvSpPr>
-          <p:cNvPr id="17" name="Oval 16"/>
+          <p:cNvPr id="18" name="Oval 17"/>
           <p:cNvSpPr/>
           <p:nvPr/>
         </p:nvSpPr>
         <p:spPr>
           <a:xfrm>
-            <a:off x="8321040" y="1828800"/>
+            <a:off x="8321040" y="2103120"/>
             <a:ext cx="512064" cy="512064"/>
           </a:xfrm>
           <a:prstGeom prst="ellipse">
@@ -11145,7 +11189,7 @@
       </p:sp>
       <p:pic>
         <p:nvPicPr>
-          <p:cNvPr id="18" name="Picture 17" descr="image-4-3.png"/>
+          <p:cNvPr id="19" name="Picture 18" descr="image-4-3.png"/>
           <p:cNvPicPr>
             <a:picLocks noChangeAspect="1"/>
           </p:cNvPicPr>
@@ -11159,7 +11203,7 @@
         </p:blipFill>
         <p:spPr>
           <a:xfrm>
-            <a:off x="8443935" y="1951695"/>
+            <a:off x="8443935" y="2226015"/>
             <a:ext cx="266273" cy="266273"/>
           </a:xfrm>
           <a:prstGeom prst="rect">
@@ -11169,13 +11213,13 @@
       </p:pic>
       <p:sp>
         <p:nvSpPr>
-          <p:cNvPr id="19" name="TextBox 18"/>
-          <p:cNvSpPr txBox="1"/>
-          <p:nvPr/>
-        </p:nvSpPr>
-        <p:spPr>
-          <a:xfrm>
-            <a:off x="8321040" y="2487168"/>
+          <p:cNvPr id="20" name="TextBox 19"/>
+          <p:cNvSpPr txBox="1"/>
+          <p:nvPr/>
+        </p:nvSpPr>
+        <p:spPr>
+          <a:xfrm>
+            <a:off x="8321040" y="2761488"/>
             <a:ext cx="3017520" cy="457200"/>
           </a:xfrm>
           <a:prstGeom prst="rect">
@@ -11204,14 +11248,14 @@
       </p:sp>
       <p:sp>
         <p:nvSpPr>
-          <p:cNvPr id="20" name="TextBox 19"/>
-          <p:cNvSpPr txBox="1"/>
-          <p:nvPr/>
-        </p:nvSpPr>
-        <p:spPr>
-          <a:xfrm>
-            <a:off x="8321040" y="2869184"/>
-            <a:ext cx="3017520" cy="1702816"/>
+          <p:cNvPr id="21" name="TextBox 20"/>
+          <p:cNvSpPr txBox="1"/>
+          <p:nvPr/>
+        </p:nvSpPr>
+        <p:spPr>
+          <a:xfrm>
+            <a:off x="8321040" y="3143504"/>
+            <a:ext cx="3017520" cy="1474216"/>
           </a:xfrm>
           <a:prstGeom prst="rect">
             <a:avLst/>
@@ -11239,7 +11283,7 @@
       </p:sp>
       <p:sp>
         <p:nvSpPr>
-          <p:cNvPr id="21" name="Rounded Rectangle 20"/>
+          <p:cNvPr id="22" name="Rounded Rectangle 21"/>
           <p:cNvSpPr/>
           <p:nvPr/>
         </p:nvSpPr>
@@ -11283,7 +11327,7 @@
       </p:sp>
       <p:sp>
         <p:nvSpPr>
-          <p:cNvPr id="22" name="TextBox 21"/>
+          <p:cNvPr id="23" name="TextBox 22"/>
           <p:cNvSpPr txBox="1"/>
           <p:nvPr/>
         </p:nvSpPr>

</xml_diff>

<commit_message>
Talk deck v4.1.1 slide 10: explain byte-wise split (32 points per shard)
Fine-tuned, vetted, and, in some cases, supplemented by Claude Sonnet 5
</commit_message>
<xml_diff>
--- a/docs/shardic_deck_v4_1_1_conference_talk.pptx
+++ b/docs/shardic_deck_v4_1_1_conference_talk.pptx
@@ -599,7 +599,7 @@
           <a:lstStyle/>
           <a:p>
             <a:r>
-              <a:t>[0:18] SSS never touches the bulk data — AES-256-GCM encrypts the archive once; Shamir splits only the 32-byte DEK. Then the step people skip: a raw Shamir point is just data, so D of them stored in the clear would rebuild the key with nobody's cooperation. Each shard is sealed under its own shardic encryption key — a codeword through Argon2id today, or a full-strength key by envelope. Finally, the .krypt file carries no trustee map: records are opaque and shuffled, and recovery tries every codeword against every record — the GCM auth tag confirms the match. With T in the tens that's instant, and the file reveals nothing about who holds what. This is what takeaway 2 means.</a:t>
+              <a:t>[0:18] SSS never touches the bulk data — AES-256-GCM encrypts the archive once; Shamir splits only the 32-byte DEK — and it does it byte by byte: 32 independent polynomials, so each shard is one x-coordinate with 32 y-values, one point per key byte. Any D shards give D points on every one of the 32 curves, and the DEK comes back a byte at a time. Then the step people skip: a raw shard is just data, so D of them stored in the clear would rebuild the key with nobody's cooperation. Each shard is sealed under its own shardic encryption key — a codeword through Argon2id today, or a full-strength key by envelope. Finally, the .krypt file carries no trustee map: records are opaque and shuffled, and recovery tries every codeword against every record — the GCM auth tag confirms the match. With T in the tens that's instant, and the file reveals nothing about who holds what. This is what takeaway 2 means.</a:t>
             </a:r>
           </a:p>
         </p:txBody>
@@ -6552,7 +6552,7 @@
                 </a:solidFill>
                 <a:latin typeface="Calibri"/>
               </a:rPr>
-              <a:t>Shamir splits only the 32-byte DEK into T shards.</a:t>
+              <a:t>One split per DEK byte: each of T shards holds 32 points. Any D rebuild all 32 bytes.</a:t>
             </a:r>
           </a:p>
         </p:txBody>
@@ -7033,7 +7033,7 @@
                 </a:solidFill>
                 <a:latin typeface="Calibri"/>
               </a:rPr>
-              <a:t>D raw Shamir points stored in the clear would rebuild the key with nobody's cooperation — so every shard is sealed before it's stored.</a:t>
+              <a:t>D raw shards stored in the clear would rebuild the key with nobody's cooperation — so every shard is sealed before it's stored.</a:t>
             </a:r>
           </a:p>
         </p:txBody>

</xml_diff>